<commit_message>
Adding network examples and updating corresponding lectures
</commit_message>
<xml_diff>
--- a/Lecture Slides/22 - Networking - Socket Programming.pptx
+++ b/Lecture Slides/22 - Networking - Socket Programming.pptx
@@ -830,6 +830,41 @@
             </a:pPr>
             <a:endParaRPr lang="en-US" dirty="0"/>
           </a:p>
+          <a:p>
+            <a:pPr marL="0" lvl="0" indent="0" algn="l" rtl="0">
+              <a:spcBef>
+                <a:spcPts val="0"/>
+              </a:spcBef>
+              <a:spcAft>
+                <a:spcPts val="0"/>
+              </a:spcAft>
+              <a:buNone/>
+            </a:pPr>
+            <a:r>
+              <a:rPr lang="en-US"/>
+              <a:t>OSI: </a:t>
+            </a:r>
+            <a:r>
+              <a:rPr lang="en-US" sz="1100">
+                <a:solidFill>
+                  <a:schemeClr val="dk2"/>
+                </a:solidFill>
+              </a:rPr>
+              <a:t>Open Systems Interconnection</a:t>
+            </a:r>
+          </a:p>
+          <a:p>
+            <a:pPr marL="0" lvl="0" indent="0" algn="l" rtl="0">
+              <a:spcBef>
+                <a:spcPts val="0"/>
+              </a:spcBef>
+              <a:spcAft>
+                <a:spcPts val="0"/>
+              </a:spcAft>
+              <a:buNone/>
+            </a:pPr>
+            <a:endParaRPr lang="en-US" dirty="0"/>
+          </a:p>
         </p:txBody>
       </p:sp>
       <p:sp>
@@ -7664,6 +7699,59 @@
               </a:spcAft>
               <a:buNone/>
             </a:pPr>
+            <a:r>
+              <a:rPr lang="en-US" b="1" dirty="0"/>
+              <a:t>Computer Memory:</a:t>
+            </a:r>
+          </a:p>
+          <a:p>
+            <a:pPr marL="0" lvl="0" indent="0" algn="l" rtl="0">
+              <a:spcBef>
+                <a:spcPts val="0"/>
+              </a:spcBef>
+              <a:spcAft>
+                <a:spcPts val="0"/>
+              </a:spcAft>
+              <a:buNone/>
+            </a:pPr>
+            <a:r>
+              <a:rPr lang="en-US" dirty="0"/>
+              <a:t>Physical memory is logically organized as a </a:t>
+            </a:r>
+            <a:r>
+              <a:rPr lang="en-US" b="1" dirty="0"/>
+              <a:t>contiguous, byte-addressable sequence</a:t>
+            </a:r>
+            <a:r>
+              <a:rPr lang="en-US" dirty="0"/>
+              <a:t>, </a:t>
+            </a:r>
+          </a:p>
+          <a:p>
+            <a:pPr marL="0" lvl="0" indent="0" algn="l" rtl="0">
+              <a:spcBef>
+                <a:spcPts val="0"/>
+              </a:spcBef>
+              <a:spcAft>
+                <a:spcPts val="0"/>
+              </a:spcAft>
+              <a:buNone/>
+            </a:pPr>
+            <a:r>
+              <a:rPr lang="en-US" dirty="0"/>
+              <a:t>where each 8-bit unit is assigned a unique numerical address.</a:t>
+            </a:r>
+          </a:p>
+          <a:p>
+            <a:pPr marL="0" lvl="0" indent="0" algn="l" rtl="0">
+              <a:spcBef>
+                <a:spcPts val="0"/>
+              </a:spcBef>
+              <a:spcAft>
+                <a:spcPts val="0"/>
+              </a:spcAft>
+              <a:buNone/>
+            </a:pPr>
             <a:endParaRPr lang="en-US" dirty="0"/>
           </a:p>
           <a:p>
@@ -7967,6 +8055,36 @@
               </a:spcAft>
               <a:buNone/>
             </a:pPr>
+            <a:r>
+              <a:rPr lang="en-US" b="1" dirty="0"/>
+              <a:t>Q. </a:t>
+            </a:r>
+            <a:r>
+              <a:rPr lang="en-US" dirty="0"/>
+              <a:t>What part of the 32-bit quantity is stored at each byte address?</a:t>
+            </a:r>
+            <a:br>
+              <a:rPr lang="en-US" dirty="0"/>
+            </a:br>
+            <a:r>
+              <a:rPr lang="en-US" b="1" dirty="0"/>
+              <a:t>A.</a:t>
+            </a:r>
+            <a:r>
+              <a:rPr lang="en-US" dirty="0"/>
+              <a:t> It depends on endianness.</a:t>
+            </a:r>
+          </a:p>
+          <a:p>
+            <a:pPr marL="0" lvl="0" indent="0" algn="l" rtl="0">
+              <a:spcBef>
+                <a:spcPts val="0"/>
+              </a:spcBef>
+              <a:spcAft>
+                <a:spcPts val="0"/>
+              </a:spcAft>
+              <a:buNone/>
+            </a:pPr>
             <a:endParaRPr lang="en-US" dirty="0"/>
           </a:p>
           <a:p>
@@ -9365,7 +9483,198 @@
               </a:spcAft>
               <a:buNone/>
             </a:pPr>
-            <a:endParaRPr/>
+            <a:r>
+              <a:rPr lang="en-US" b="1" dirty="0"/>
+              <a:t>Byte Order (Endianness)</a:t>
+            </a:r>
+            <a:r>
+              <a:rPr lang="en-US" dirty="0"/>
+              <a:t>:</a:t>
+            </a:r>
+          </a:p>
+          <a:p>
+            <a:pPr marL="171450" lvl="0" indent="-171450" algn="l" rtl="0">
+              <a:spcBef>
+                <a:spcPts val="0"/>
+              </a:spcBef>
+              <a:spcAft>
+                <a:spcPts val="0"/>
+              </a:spcAft>
+            </a:pPr>
+            <a:r>
+              <a:rPr lang="en-US" sz="1100" b="1" i="0" u="none" strike="noStrike" cap="none" dirty="0">
+                <a:solidFill>
+                  <a:srgbClr val="000000"/>
+                </a:solidFill>
+                <a:effectLst/>
+                <a:latin typeface="Arial"/>
+                <a:ea typeface="Arial"/>
+                <a:cs typeface="Arial"/>
+                <a:sym typeface="Arial"/>
+              </a:rPr>
+              <a:t>Big-Endian (Network Byte Order)</a:t>
+            </a:r>
+            <a:r>
+              <a:rPr lang="en-US" sz="1100" b="0" i="0" u="none" strike="noStrike" cap="none" dirty="0">
+                <a:solidFill>
+                  <a:srgbClr val="000000"/>
+                </a:solidFill>
+                <a:effectLst/>
+                <a:latin typeface="Arial"/>
+                <a:ea typeface="Arial"/>
+                <a:cs typeface="Arial"/>
+                <a:sym typeface="Arial"/>
+              </a:rPr>
+              <a:t>: </a:t>
+            </a:r>
+            <a:br>
+              <a:rPr lang="en-US" sz="1100" b="0" i="0" u="none" strike="noStrike" cap="none" dirty="0">
+                <a:solidFill>
+                  <a:srgbClr val="000000"/>
+                </a:solidFill>
+                <a:effectLst/>
+                <a:latin typeface="Arial"/>
+                <a:ea typeface="Arial"/>
+                <a:cs typeface="Arial"/>
+                <a:sym typeface="Arial"/>
+              </a:rPr>
+            </a:br>
+            <a:r>
+              <a:rPr lang="en-US" sz="1100" b="0" i="0" u="none" strike="noStrike" cap="none" dirty="0">
+                <a:solidFill>
+                  <a:srgbClr val="000000"/>
+                </a:solidFill>
+                <a:effectLst/>
+                <a:latin typeface="Arial"/>
+                <a:ea typeface="Arial"/>
+                <a:cs typeface="Arial"/>
+                <a:sym typeface="Arial"/>
+              </a:rPr>
+              <a:t>Most significant byte (MSB) is stored at the lowest address. </a:t>
+            </a:r>
+            <a:br>
+              <a:rPr lang="en-US" sz="1100" b="0" i="0" u="none" strike="noStrike" cap="none" dirty="0">
+                <a:solidFill>
+                  <a:srgbClr val="000000"/>
+                </a:solidFill>
+                <a:effectLst/>
+                <a:latin typeface="Arial"/>
+                <a:ea typeface="Arial"/>
+                <a:cs typeface="Arial"/>
+                <a:sym typeface="Arial"/>
+              </a:rPr>
+            </a:br>
+            <a:r>
+              <a:rPr lang="en-US" sz="1100" b="0" i="0" u="none" strike="noStrike" cap="none" dirty="0">
+                <a:solidFill>
+                  <a:srgbClr val="000000"/>
+                </a:solidFill>
+                <a:effectLst/>
+                <a:latin typeface="Arial"/>
+                <a:ea typeface="Arial"/>
+                <a:cs typeface="Arial"/>
+                <a:sym typeface="Arial"/>
+              </a:rPr>
+              <a:t>Used for transmitting data over networks.</a:t>
+            </a:r>
+          </a:p>
+          <a:p>
+            <a:pPr marL="171450" lvl="0" indent="-171450" algn="l" rtl="0">
+              <a:spcBef>
+                <a:spcPts val="0"/>
+              </a:spcBef>
+              <a:spcAft>
+                <a:spcPts val="0"/>
+              </a:spcAft>
+            </a:pPr>
+            <a:r>
+              <a:rPr lang="en-US" sz="1100" b="1" i="0" u="none" strike="noStrike" cap="none" dirty="0">
+                <a:solidFill>
+                  <a:srgbClr val="000000"/>
+                </a:solidFill>
+                <a:effectLst/>
+                <a:latin typeface="Arial"/>
+                <a:ea typeface="Arial"/>
+                <a:cs typeface="Arial"/>
+                <a:sym typeface="Arial"/>
+              </a:rPr>
+              <a:t>Little-Endian (Host Byte Order)</a:t>
+            </a:r>
+            <a:r>
+              <a:rPr lang="en-US" sz="1100" b="0" i="0" u="none" strike="noStrike" cap="none" dirty="0">
+                <a:solidFill>
+                  <a:srgbClr val="000000"/>
+                </a:solidFill>
+                <a:effectLst/>
+                <a:latin typeface="Arial"/>
+                <a:ea typeface="Arial"/>
+                <a:cs typeface="Arial"/>
+                <a:sym typeface="Arial"/>
+              </a:rPr>
+              <a:t>: </a:t>
+            </a:r>
+            <a:br>
+              <a:rPr lang="en-US" sz="1100" b="0" i="0" u="none" strike="noStrike" cap="none" dirty="0">
+                <a:solidFill>
+                  <a:srgbClr val="000000"/>
+                </a:solidFill>
+                <a:effectLst/>
+                <a:latin typeface="Arial"/>
+                <a:ea typeface="Arial"/>
+                <a:cs typeface="Arial"/>
+                <a:sym typeface="Arial"/>
+              </a:rPr>
+            </a:br>
+            <a:r>
+              <a:rPr lang="en-US" sz="1100" b="0" i="0" u="none" strike="noStrike" cap="none" dirty="0">
+                <a:solidFill>
+                  <a:srgbClr val="000000"/>
+                </a:solidFill>
+                <a:effectLst/>
+                <a:latin typeface="Arial"/>
+                <a:ea typeface="Arial"/>
+                <a:cs typeface="Arial"/>
+                <a:sym typeface="Arial"/>
+              </a:rPr>
+              <a:t>Least significant byte (LSB) is at the lowest address. </a:t>
+            </a:r>
+            <a:br>
+              <a:rPr lang="en-US" sz="1100" b="0" i="0" u="none" strike="noStrike" cap="none" dirty="0">
+                <a:solidFill>
+                  <a:srgbClr val="000000"/>
+                </a:solidFill>
+                <a:effectLst/>
+                <a:latin typeface="Arial"/>
+                <a:ea typeface="Arial"/>
+                <a:cs typeface="Arial"/>
+                <a:sym typeface="Arial"/>
+              </a:rPr>
+            </a:br>
+            <a:r>
+              <a:rPr lang="en-US" sz="1100" b="0" i="0" u="none" strike="noStrike" cap="none" dirty="0">
+                <a:solidFill>
+                  <a:srgbClr val="000000"/>
+                </a:solidFill>
+                <a:effectLst/>
+                <a:latin typeface="Arial"/>
+                <a:ea typeface="Arial"/>
+                <a:cs typeface="Arial"/>
+                <a:sym typeface="Arial"/>
+              </a:rPr>
+              <a:t>Common in x86-based CPUs for efficient processing.</a:t>
+            </a:r>
+          </a:p>
+          <a:p>
+            <a:pPr marL="0" lvl="0" indent="0" algn="l" rtl="0">
+              <a:spcBef>
+                <a:spcPts val="0"/>
+              </a:spcBef>
+              <a:spcAft>
+                <a:spcPts val="0"/>
+              </a:spcAft>
+              <a:buNone/>
+            </a:pPr>
+            <a:endParaRPr dirty="0"/>
           </a:p>
         </p:txBody>
       </p:sp>
@@ -9469,7 +9778,616 @@
               </a:spcAft>
               <a:buNone/>
             </a:pPr>
-            <a:endParaRPr/>
+            <a:r>
+              <a:rPr lang="en-US" b="1" dirty="0"/>
+              <a:t>Byte Order (Endianness)</a:t>
+            </a:r>
+            <a:r>
+              <a:rPr lang="en-US" dirty="0"/>
+              <a:t>:</a:t>
+            </a:r>
+          </a:p>
+          <a:p>
+            <a:pPr marL="171450" lvl="0" indent="-171450" algn="l" rtl="0">
+              <a:spcBef>
+                <a:spcPts val="0"/>
+              </a:spcBef>
+              <a:spcAft>
+                <a:spcPts val="0"/>
+              </a:spcAft>
+            </a:pPr>
+            <a:r>
+              <a:rPr lang="en-US" sz="1100" b="1" i="0" u="none" strike="noStrike" cap="none" dirty="0">
+                <a:solidFill>
+                  <a:srgbClr val="000000"/>
+                </a:solidFill>
+                <a:effectLst/>
+                <a:latin typeface="Arial"/>
+                <a:ea typeface="Arial"/>
+                <a:cs typeface="Arial"/>
+                <a:sym typeface="Arial"/>
+              </a:rPr>
+              <a:t>Big-Endian (Network Byte Order)</a:t>
+            </a:r>
+            <a:r>
+              <a:rPr lang="en-US" sz="1100" b="0" i="0" u="none" strike="noStrike" cap="none" dirty="0">
+                <a:solidFill>
+                  <a:srgbClr val="000000"/>
+                </a:solidFill>
+                <a:effectLst/>
+                <a:latin typeface="Arial"/>
+                <a:ea typeface="Arial"/>
+                <a:cs typeface="Arial"/>
+                <a:sym typeface="Arial"/>
+              </a:rPr>
+              <a:t>: </a:t>
+            </a:r>
+            <a:br>
+              <a:rPr lang="en-US" sz="1100" b="0" i="0" u="none" strike="noStrike" cap="none" dirty="0">
+                <a:solidFill>
+                  <a:srgbClr val="000000"/>
+                </a:solidFill>
+                <a:effectLst/>
+                <a:latin typeface="Arial"/>
+                <a:ea typeface="Arial"/>
+                <a:cs typeface="Arial"/>
+                <a:sym typeface="Arial"/>
+              </a:rPr>
+            </a:br>
+            <a:r>
+              <a:rPr lang="en-US" sz="1100" b="0" i="0" u="none" strike="noStrike" cap="none" dirty="0">
+                <a:solidFill>
+                  <a:srgbClr val="000000"/>
+                </a:solidFill>
+                <a:effectLst/>
+                <a:latin typeface="Arial"/>
+                <a:ea typeface="Arial"/>
+                <a:cs typeface="Arial"/>
+                <a:sym typeface="Arial"/>
+              </a:rPr>
+              <a:t>Most significant byte (MSB) is stored at the lowest address. </a:t>
+            </a:r>
+            <a:br>
+              <a:rPr lang="en-US" sz="1100" b="0" i="0" u="none" strike="noStrike" cap="none" dirty="0">
+                <a:solidFill>
+                  <a:srgbClr val="000000"/>
+                </a:solidFill>
+                <a:effectLst/>
+                <a:latin typeface="Arial"/>
+                <a:ea typeface="Arial"/>
+                <a:cs typeface="Arial"/>
+                <a:sym typeface="Arial"/>
+              </a:rPr>
+            </a:br>
+            <a:r>
+              <a:rPr lang="en-US" sz="1100" b="0" i="0" u="none" strike="noStrike" cap="none" dirty="0">
+                <a:solidFill>
+                  <a:srgbClr val="000000"/>
+                </a:solidFill>
+                <a:effectLst/>
+                <a:latin typeface="Arial"/>
+                <a:ea typeface="Arial"/>
+                <a:cs typeface="Arial"/>
+                <a:sym typeface="Arial"/>
+              </a:rPr>
+              <a:t>Used for transmitting data over networks.</a:t>
+            </a:r>
+          </a:p>
+          <a:p>
+            <a:pPr marL="171450" lvl="0" indent="-171450" algn="l" rtl="0">
+              <a:spcBef>
+                <a:spcPts val="0"/>
+              </a:spcBef>
+              <a:spcAft>
+                <a:spcPts val="0"/>
+              </a:spcAft>
+            </a:pPr>
+            <a:r>
+              <a:rPr lang="en-US" sz="1100" b="1" i="0" u="none" strike="noStrike" cap="none" dirty="0">
+                <a:solidFill>
+                  <a:srgbClr val="000000"/>
+                </a:solidFill>
+                <a:effectLst/>
+                <a:latin typeface="Arial"/>
+                <a:ea typeface="Arial"/>
+                <a:cs typeface="Arial"/>
+                <a:sym typeface="Arial"/>
+              </a:rPr>
+              <a:t>Little-Endian (Host Byte Order)</a:t>
+            </a:r>
+            <a:r>
+              <a:rPr lang="en-US" sz="1100" b="0" i="0" u="none" strike="noStrike" cap="none" dirty="0">
+                <a:solidFill>
+                  <a:srgbClr val="000000"/>
+                </a:solidFill>
+                <a:effectLst/>
+                <a:latin typeface="Arial"/>
+                <a:ea typeface="Arial"/>
+                <a:cs typeface="Arial"/>
+                <a:sym typeface="Arial"/>
+              </a:rPr>
+              <a:t>: </a:t>
+            </a:r>
+            <a:br>
+              <a:rPr lang="en-US" sz="1100" b="0" i="0" u="none" strike="noStrike" cap="none" dirty="0">
+                <a:solidFill>
+                  <a:srgbClr val="000000"/>
+                </a:solidFill>
+                <a:effectLst/>
+                <a:latin typeface="Arial"/>
+                <a:ea typeface="Arial"/>
+                <a:cs typeface="Arial"/>
+                <a:sym typeface="Arial"/>
+              </a:rPr>
+            </a:br>
+            <a:r>
+              <a:rPr lang="en-US" sz="1100" b="0" i="0" u="none" strike="noStrike" cap="none" dirty="0">
+                <a:solidFill>
+                  <a:srgbClr val="000000"/>
+                </a:solidFill>
+                <a:effectLst/>
+                <a:latin typeface="Arial"/>
+                <a:ea typeface="Arial"/>
+                <a:cs typeface="Arial"/>
+                <a:sym typeface="Arial"/>
+              </a:rPr>
+              <a:t>Least significant byte (LSB) is at the lowest address. </a:t>
+            </a:r>
+            <a:br>
+              <a:rPr lang="en-US" sz="1100" b="0" i="0" u="none" strike="noStrike" cap="none" dirty="0">
+                <a:solidFill>
+                  <a:srgbClr val="000000"/>
+                </a:solidFill>
+                <a:effectLst/>
+                <a:latin typeface="Arial"/>
+                <a:ea typeface="Arial"/>
+                <a:cs typeface="Arial"/>
+                <a:sym typeface="Arial"/>
+              </a:rPr>
+            </a:br>
+            <a:r>
+              <a:rPr lang="en-US" sz="1100" b="0" i="0" u="none" strike="noStrike" cap="none" dirty="0">
+                <a:solidFill>
+                  <a:srgbClr val="000000"/>
+                </a:solidFill>
+                <a:effectLst/>
+                <a:latin typeface="Arial"/>
+                <a:ea typeface="Arial"/>
+                <a:cs typeface="Arial"/>
+                <a:sym typeface="Arial"/>
+              </a:rPr>
+              <a:t>Common in x86-based CPUs for efficient processing.</a:t>
+            </a:r>
+          </a:p>
+          <a:p>
+            <a:pPr marL="0" lvl="0" indent="0" algn="l" rtl="0">
+              <a:spcBef>
+                <a:spcPts val="0"/>
+              </a:spcBef>
+              <a:spcAft>
+                <a:spcPts val="0"/>
+              </a:spcAft>
+              <a:buNone/>
+            </a:pPr>
+            <a:endParaRPr lang="en-US" dirty="0"/>
+          </a:p>
+          <a:p>
+            <a:pPr marL="0" lvl="0" indent="0" algn="l" rtl="0">
+              <a:spcBef>
+                <a:spcPts val="0"/>
+              </a:spcBef>
+              <a:spcAft>
+                <a:spcPts val="0"/>
+              </a:spcAft>
+              <a:buNone/>
+            </a:pPr>
+            <a:endParaRPr lang="en-US" dirty="0"/>
+          </a:p>
+          <a:p>
+            <a:pPr marL="0" lvl="0" indent="0" algn="l" rtl="0">
+              <a:spcBef>
+                <a:spcPts val="0"/>
+              </a:spcBef>
+              <a:spcAft>
+                <a:spcPts val="0"/>
+              </a:spcAft>
+              <a:buNone/>
+            </a:pPr>
+            <a:r>
+              <a:rPr lang="en-US" dirty="0"/>
+              <a:t>---</a:t>
+            </a:r>
+          </a:p>
+          <a:p>
+            <a:pPr marL="0" lvl="0" indent="0" algn="l" rtl="0">
+              <a:spcBef>
+                <a:spcPts val="0"/>
+              </a:spcBef>
+              <a:spcAft>
+                <a:spcPts val="0"/>
+              </a:spcAft>
+              <a:buNone/>
+            </a:pPr>
+            <a:r>
+              <a:rPr lang="en-US" i="1" u="sng" dirty="0"/>
+              <a:t>For Reference:</a:t>
+            </a:r>
+          </a:p>
+          <a:p>
+            <a:pPr marL="0" lvl="0" indent="0" algn="l" rtl="0">
+              <a:spcBef>
+                <a:spcPts val="0"/>
+              </a:spcBef>
+              <a:spcAft>
+                <a:spcPts val="0"/>
+              </a:spcAft>
+              <a:buNone/>
+            </a:pPr>
+            <a:endParaRPr lang="en-US" dirty="0"/>
+          </a:p>
+          <a:p>
+            <a:pPr marL="0" lvl="0" indent="0" algn="l" rtl="0">
+              <a:spcBef>
+                <a:spcPts val="0"/>
+              </a:spcBef>
+              <a:spcAft>
+                <a:spcPts val="0"/>
+              </a:spcAft>
+              <a:buNone/>
+            </a:pPr>
+            <a:r>
+              <a:rPr lang="en-US" b="1" dirty="0"/>
+              <a:t>Architectural Breakdown</a:t>
+            </a:r>
+          </a:p>
+          <a:p>
+            <a:pPr marL="0" lvl="0" indent="0" algn="l" rtl="0">
+              <a:spcBef>
+                <a:spcPts val="0"/>
+              </a:spcBef>
+              <a:spcAft>
+                <a:spcPts val="0"/>
+              </a:spcAft>
+              <a:buNone/>
+            </a:pPr>
+            <a:r>
+              <a:rPr lang="en-US" dirty="0"/>
+              <a:t>The choice of endianness is a fundamental design decision of the Instruction Set Architecture (ISA).</a:t>
+            </a:r>
+          </a:p>
+          <a:p>
+            <a:pPr marL="0" lvl="0" indent="0" algn="l" rtl="0">
+              <a:spcBef>
+                <a:spcPts val="0"/>
+              </a:spcBef>
+              <a:spcAft>
+                <a:spcPts val="0"/>
+              </a:spcAft>
+              <a:buNone/>
+            </a:pPr>
+            <a:endParaRPr lang="en-US" b="1" dirty="0"/>
+          </a:p>
+          <a:p>
+            <a:pPr marL="228600" lvl="0" indent="-228600" algn="l" rtl="0">
+              <a:spcBef>
+                <a:spcPts val="0"/>
+              </a:spcBef>
+              <a:spcAft>
+                <a:spcPts val="0"/>
+              </a:spcAft>
+              <a:buAutoNum type="arabicPeriod"/>
+            </a:pPr>
+            <a:r>
+              <a:rPr lang="en-US" b="1" dirty="0"/>
+              <a:t>Little-Endian Architectures</a:t>
+            </a:r>
+          </a:p>
+          <a:p>
+            <a:pPr marL="0" lvl="0" indent="0" algn="l" rtl="0">
+              <a:spcBef>
+                <a:spcPts val="0"/>
+              </a:spcBef>
+              <a:spcAft>
+                <a:spcPts val="0"/>
+              </a:spcAft>
+              <a:buNone/>
+            </a:pPr>
+            <a:r>
+              <a:rPr lang="en-US" dirty="0"/>
+              <a:t>This is currently the most dominant order in consumer and enterprise computing.</a:t>
+            </a:r>
+          </a:p>
+          <a:p>
+            <a:pPr marL="228600" lvl="0" indent="-228600" algn="l" rtl="0">
+              <a:spcBef>
+                <a:spcPts val="0"/>
+              </a:spcBef>
+              <a:spcAft>
+                <a:spcPts val="0"/>
+              </a:spcAft>
+            </a:pPr>
+            <a:r>
+              <a:rPr lang="en-US" b="1" dirty="0"/>
+              <a:t>x86 and x86-64:</a:t>
+            </a:r>
+            <a:r>
+              <a:rPr lang="en-US" dirty="0"/>
+              <a:t> All Intel and AMD processors use little-endian.</a:t>
+            </a:r>
+          </a:p>
+          <a:p>
+            <a:pPr marL="228600" lvl="0" indent="-228600" algn="l" rtl="0">
+              <a:spcBef>
+                <a:spcPts val="0"/>
+              </a:spcBef>
+              <a:spcAft>
+                <a:spcPts val="0"/>
+              </a:spcAft>
+            </a:pPr>
+            <a:r>
+              <a:rPr lang="en-US" b="1" dirty="0"/>
+              <a:t>RISC-V:</a:t>
+            </a:r>
+            <a:r>
+              <a:rPr lang="en-US" dirty="0"/>
+              <a:t> By default, RISC-V is little-endian, though the specification allows for big-endian versions.</a:t>
+            </a:r>
+          </a:p>
+          <a:p>
+            <a:pPr marL="228600" lvl="0" indent="-228600" algn="l" rtl="0">
+              <a:spcBef>
+                <a:spcPts val="0"/>
+              </a:spcBef>
+              <a:spcAft>
+                <a:spcPts val="0"/>
+              </a:spcAft>
+            </a:pPr>
+            <a:r>
+              <a:rPr lang="en-US" b="1" dirty="0"/>
+              <a:t>iOS/Android Mobile Devices:</a:t>
+            </a:r>
+            <a:r>
+              <a:rPr lang="en-US" dirty="0"/>
+              <a:t> While the underlying ARM chips are technically capable of both, almost all mobile operating systems run exclusively in little-endian mode.</a:t>
+            </a:r>
+          </a:p>
+          <a:p>
+            <a:pPr marL="0" lvl="0" indent="0" algn="l" rtl="0">
+              <a:spcBef>
+                <a:spcPts val="0"/>
+              </a:spcBef>
+              <a:spcAft>
+                <a:spcPts val="0"/>
+              </a:spcAft>
+              <a:buNone/>
+            </a:pPr>
+            <a:endParaRPr lang="en-US" b="1" dirty="0"/>
+          </a:p>
+          <a:p>
+            <a:pPr marL="0" lvl="0" indent="0" algn="l" rtl="0">
+              <a:spcBef>
+                <a:spcPts val="0"/>
+              </a:spcBef>
+              <a:spcAft>
+                <a:spcPts val="0"/>
+              </a:spcAft>
+              <a:buNone/>
+            </a:pPr>
+            <a:r>
+              <a:rPr lang="en-US" b="1" dirty="0"/>
+              <a:t>2. Big-Endian Architectures</a:t>
+            </a:r>
+          </a:p>
+          <a:p>
+            <a:pPr marL="0" lvl="0" indent="0" algn="l" rtl="0">
+              <a:spcBef>
+                <a:spcPts val="0"/>
+              </a:spcBef>
+              <a:spcAft>
+                <a:spcPts val="0"/>
+              </a:spcAft>
+              <a:buNone/>
+            </a:pPr>
+            <a:r>
+              <a:rPr lang="en-US" dirty="0"/>
+              <a:t>Big-endian was the standard for many years in high-end workstations and networking hardware.</a:t>
+            </a:r>
+          </a:p>
+          <a:p>
+            <a:pPr marL="171450" lvl="0" indent="-171450" algn="l" rtl="0">
+              <a:spcBef>
+                <a:spcPts val="0"/>
+              </a:spcBef>
+              <a:spcAft>
+                <a:spcPts val="0"/>
+              </a:spcAft>
+            </a:pPr>
+            <a:r>
+              <a:rPr lang="en-US" b="1" dirty="0"/>
+              <a:t>IBM z/Architecture (Mainframes):</a:t>
+            </a:r>
+            <a:r>
+              <a:rPr lang="en-US" dirty="0"/>
+              <a:t> Consistently big-endian.</a:t>
+            </a:r>
+          </a:p>
+          <a:p>
+            <a:pPr marL="171450" lvl="0" indent="-171450" algn="l" rtl="0">
+              <a:spcBef>
+                <a:spcPts val="0"/>
+              </a:spcBef>
+              <a:spcAft>
+                <a:spcPts val="0"/>
+              </a:spcAft>
+            </a:pPr>
+            <a:r>
+              <a:rPr lang="en-US" b="1" dirty="0"/>
+              <a:t>Motorola 68000 &amp; early SPARC:</a:t>
+            </a:r>
+            <a:r>
+              <a:rPr lang="en-US" dirty="0"/>
+              <a:t> Classic workstation architectures.</a:t>
+            </a:r>
+          </a:p>
+          <a:p>
+            <a:pPr marL="171450" lvl="0" indent="-171450" algn="l" rtl="0">
+              <a:spcBef>
+                <a:spcPts val="0"/>
+              </a:spcBef>
+              <a:spcAft>
+                <a:spcPts val="0"/>
+              </a:spcAft>
+            </a:pPr>
+            <a:r>
+              <a:rPr lang="en-US" b="1" dirty="0"/>
+              <a:t>PowerPC (Legacy):</a:t>
+            </a:r>
+            <a:r>
+              <a:rPr lang="en-US" dirty="0"/>
+              <a:t> Older Mac hardware (G3, G4, G5) was big-endian.</a:t>
+            </a:r>
+          </a:p>
+          <a:p>
+            <a:pPr marL="171450" lvl="0" indent="-171450" algn="l" rtl="0">
+              <a:spcBef>
+                <a:spcPts val="0"/>
+              </a:spcBef>
+              <a:spcAft>
+                <a:spcPts val="0"/>
+              </a:spcAft>
+            </a:pPr>
+            <a:r>
+              <a:rPr lang="en-US" b="1" dirty="0"/>
+              <a:t>Network Protocols:</a:t>
+            </a:r>
+            <a:r>
+              <a:rPr lang="en-US" dirty="0"/>
+              <a:t> Often called </a:t>
+            </a:r>
+            <a:r>
+              <a:rPr lang="en-US" b="1" dirty="0"/>
+              <a:t>"Network Byte Order."</a:t>
+            </a:r>
+            <a:r>
+              <a:rPr lang="en-US" dirty="0"/>
+              <a:t> Regardless of the CPU architecture, protocols like TCP/IP require data to be transmitted in big-endian format.</a:t>
+            </a:r>
+          </a:p>
+          <a:p>
+            <a:pPr marL="0" lvl="0" indent="0" algn="l" rtl="0">
+              <a:spcBef>
+                <a:spcPts val="0"/>
+              </a:spcBef>
+              <a:spcAft>
+                <a:spcPts val="0"/>
+              </a:spcAft>
+              <a:buNone/>
+            </a:pPr>
+            <a:endParaRPr lang="en-US" b="1" dirty="0"/>
+          </a:p>
+          <a:p>
+            <a:pPr marL="0" lvl="0" indent="0" algn="l" rtl="0">
+              <a:spcBef>
+                <a:spcPts val="0"/>
+              </a:spcBef>
+              <a:spcAft>
+                <a:spcPts val="0"/>
+              </a:spcAft>
+              <a:buNone/>
+            </a:pPr>
+            <a:r>
+              <a:rPr lang="en-US" b="1" dirty="0"/>
+              <a:t>3. Bi-Endian Architectures</a:t>
+            </a:r>
+          </a:p>
+          <a:p>
+            <a:pPr marL="0" lvl="0" indent="0" algn="l" rtl="0">
+              <a:spcBef>
+                <a:spcPts val="0"/>
+              </a:spcBef>
+              <a:spcAft>
+                <a:spcPts val="0"/>
+              </a:spcAft>
+              <a:buNone/>
+            </a:pPr>
+            <a:r>
+              <a:rPr lang="en-US" dirty="0"/>
+              <a:t>Many modern architectures are "switchable," meaning the processor can be configured to operate in either mode at boot or via a state bit.</a:t>
+            </a:r>
+          </a:p>
+          <a:p>
+            <a:pPr marL="171450" lvl="0" indent="-171450" algn="l" rtl="0">
+              <a:spcBef>
+                <a:spcPts val="0"/>
+              </a:spcBef>
+              <a:spcAft>
+                <a:spcPts val="0"/>
+              </a:spcAft>
+            </a:pPr>
+            <a:r>
+              <a:rPr lang="en-US" b="1" dirty="0"/>
+              <a:t>ARM (v7, v8, v9):</a:t>
+            </a:r>
+            <a:r>
+              <a:rPr lang="en-US" dirty="0"/>
+              <a:t> Supports both, but as noted, little-endian is the industry standard for OS implementations.</a:t>
+            </a:r>
+          </a:p>
+          <a:p>
+            <a:pPr marL="171450" lvl="0" indent="-171450" algn="l" rtl="0">
+              <a:spcBef>
+                <a:spcPts val="0"/>
+              </a:spcBef>
+              <a:spcAft>
+                <a:spcPts val="0"/>
+              </a:spcAft>
+            </a:pPr>
+            <a:r>
+              <a:rPr lang="en-US" b="1" dirty="0"/>
+              <a:t>POWER/PowerPC:</a:t>
+            </a:r>
+            <a:r>
+              <a:rPr lang="en-US" dirty="0"/>
+              <a:t> Modern Power processors (like those in IBM’s POWER9 servers) can switch, though most modern Linux distributions on Power run in "Little-Endian" mode (PPC64LE).</a:t>
+            </a:r>
+          </a:p>
+          <a:p>
+            <a:pPr marL="171450" lvl="0" indent="-171450" algn="l" rtl="0">
+              <a:spcBef>
+                <a:spcPts val="0"/>
+              </a:spcBef>
+              <a:spcAft>
+                <a:spcPts val="0"/>
+              </a:spcAft>
+            </a:pPr>
+            <a:r>
+              <a:rPr lang="en-US" b="1" dirty="0"/>
+              <a:t>MIPS:</a:t>
+            </a:r>
+            <a:r>
+              <a:rPr lang="en-US" dirty="0"/>
+              <a:t> Historically used in both configurations (e.g., the Nintendo 64 was big-endian, while some </a:t>
+            </a:r>
+            <a:r>
+              <a:rPr lang="en-US" dirty="0" err="1"/>
+              <a:t>DECstations</a:t>
+            </a:r>
+            <a:r>
+              <a:rPr lang="en-US" dirty="0"/>
+              <a:t> were little-endian).</a:t>
+            </a:r>
+          </a:p>
+          <a:p>
+            <a:pPr marL="0" lvl="0" indent="0" algn="l" rtl="0">
+              <a:spcBef>
+                <a:spcPts val="0"/>
+              </a:spcBef>
+              <a:spcAft>
+                <a:spcPts val="0"/>
+              </a:spcAft>
+              <a:buNone/>
+            </a:pPr>
+            <a:endParaRPr lang="en-US" dirty="0"/>
           </a:p>
         </p:txBody>
       </p:sp>
@@ -36806,7 +37724,7 @@
               <a:defRPr/>
             </a:pPr>
             <a:r>
-              <a:rPr kumimoji="0" sz="1500" b="1" i="0" u="none" strike="noStrike" kern="0" cap="none" spc="0" normalizeH="0" baseline="0" noProof="0" dirty="0">
+              <a:rPr kumimoji="0" sz="1500" i="0" u="none" strike="noStrike" kern="0" cap="none" spc="0" normalizeH="0" baseline="0" noProof="0" dirty="0">
                 <a:ln>
                   <a:noFill/>
                 </a:ln>
@@ -36822,7 +37740,7 @@
               <a:t>TCP/IP</a:t>
             </a:r>
             <a:r>
-              <a:rPr kumimoji="0" sz="1500" b="1" i="0" u="none" strike="noStrike" kern="0" cap="none" spc="-55" normalizeH="0" baseline="0" noProof="0" dirty="0">
+              <a:rPr kumimoji="0" sz="1500" i="0" u="none" strike="noStrike" kern="0" cap="none" spc="-55" normalizeH="0" baseline="0" noProof="0" dirty="0">
                 <a:ln>
                   <a:noFill/>
                 </a:ln>
@@ -36838,7 +37756,7 @@
               <a:t> </a:t>
             </a:r>
             <a:r>
-              <a:rPr kumimoji="0" sz="1500" b="1" i="0" u="none" strike="noStrike" kern="0" cap="none" spc="-10" normalizeH="0" baseline="0" noProof="0" dirty="0">
+              <a:rPr kumimoji="0" sz="1500" i="0" u="none" strike="noStrike" kern="0" cap="none" spc="-10" normalizeH="0" baseline="0" noProof="0" dirty="0">
                 <a:ln>
                   <a:noFill/>
                 </a:ln>
@@ -36853,7 +37771,7 @@
               </a:rPr>
               <a:t>Model</a:t>
             </a:r>
-            <a:endParaRPr kumimoji="0" sz="1500" b="1" i="0" u="none" strike="noStrike" kern="0" cap="none" spc="0" normalizeH="0" baseline="0" noProof="0" dirty="0">
+            <a:endParaRPr kumimoji="0" sz="1500" i="0" u="none" strike="noStrike" kern="0" cap="none" spc="0" normalizeH="0" baseline="0" noProof="0" dirty="0">
               <a:ln>
                 <a:noFill/>
               </a:ln>

</xml_diff>